<commit_message>
Polish presentation slides 4 and 5
</commit_message>
<xml_diff>
--- a/docs/presentation/verdant-presentation.pptx
+++ b/docs/presentation/verdant-presentation.pptx
@@ -18372,8 +18372,8 @@
         </p:nvSpPr>
         <p:spPr>
           <a:xfrm>
-            <a:off x="342736" y="2200000"/>
-            <a:ext cx="2650000" cy="600000"/>
+            <a:off x="342736" y="2040000"/>
+            <a:ext cx="2650000" cy="520000"/>
           </a:xfrm>
           <a:prstGeom prst="rect">
             <a:avLst/>
@@ -18412,8 +18412,8 @@
         </p:nvSpPr>
         <p:spPr>
           <a:xfrm>
-            <a:off x="3239948" y="2200000"/>
-            <a:ext cx="2650000" cy="600000"/>
+            <a:off x="3239948" y="2040000"/>
+            <a:ext cx="2650000" cy="520000"/>
           </a:xfrm>
           <a:prstGeom prst="rect">
             <a:avLst/>
@@ -18452,8 +18452,8 @@
         </p:nvSpPr>
         <p:spPr>
           <a:xfrm>
-            <a:off x="6132612" y="2200000"/>
-            <a:ext cx="2650000" cy="600000"/>
+            <a:off x="6132612" y="2040000"/>
+            <a:ext cx="2650000" cy="520000"/>
           </a:xfrm>
           <a:prstGeom prst="rect">
             <a:avLst/>
@@ -18492,7 +18492,7 @@
         </p:nvSpPr>
         <p:spPr>
           <a:xfrm>
-            <a:off x="6132612" y="1750000"/>
+            <a:off x="6132612" y="1590000"/>
             <a:ext cx="2650000" cy="450000"/>
           </a:xfrm>
           <a:prstGeom prst="rect">
@@ -18532,7 +18532,7 @@
         </p:nvSpPr>
         <p:spPr>
           <a:xfrm>
-            <a:off x="3239948" y="1750000"/>
+            <a:off x="3239948" y="1590000"/>
             <a:ext cx="2650000" cy="450000"/>
           </a:xfrm>
           <a:prstGeom prst="rect">
@@ -18572,7 +18572,7 @@
         </p:nvSpPr>
         <p:spPr>
           <a:xfrm>
-            <a:off x="342736" y="1750000"/>
+            <a:off x="342736" y="1590000"/>
             <a:ext cx="2650000" cy="450000"/>
           </a:xfrm>
           <a:prstGeom prst="rect">
@@ -18617,7 +18617,7 @@
         </p:blipFill>
         <p:spPr>
           <a:xfrm>
-            <a:off x="422861" y="3001875"/>
+            <a:off x="422861" y="2590000"/>
             <a:ext cx="2472600" cy="265500"/>
           </a:xfrm>
           <a:prstGeom prst="rect">
@@ -18641,8 +18641,8 @@
         </p:blipFill>
         <p:spPr>
           <a:xfrm>
-            <a:off x="434161" y="3250000"/>
-            <a:ext cx="2450000" cy="760000"/>
+            <a:off x="434161" y="2855500"/>
+            <a:ext cx="2450000" cy="1075000"/>
           </a:xfrm>
           <a:prstGeom prst="rect">
             <a:avLst/>
@@ -18669,7 +18669,7 @@
         </p:blipFill>
         <p:spPr>
           <a:xfrm>
-            <a:off x="3320073" y="3001875"/>
+            <a:off x="3320073" y="2590000"/>
             <a:ext cx="2472600" cy="265500"/>
           </a:xfrm>
           <a:prstGeom prst="rect">
@@ -18693,8 +18693,8 @@
         </p:blipFill>
         <p:spPr>
           <a:xfrm>
-            <a:off x="3331373" y="3250000"/>
-            <a:ext cx="2450000" cy="760000"/>
+            <a:off x="3331373" y="2855500"/>
+            <a:ext cx="2450000" cy="1075000"/>
           </a:xfrm>
           <a:prstGeom prst="rect">
             <a:avLst/>
@@ -18721,7 +18721,7 @@
         </p:blipFill>
         <p:spPr>
           <a:xfrm>
-            <a:off x="6212737" y="3001875"/>
+            <a:off x="6212737" y="2590000"/>
             <a:ext cx="2472600" cy="265500"/>
           </a:xfrm>
           <a:prstGeom prst="rect">
@@ -18745,8 +18745,8 @@
         </p:blipFill>
         <p:spPr>
           <a:xfrm>
-            <a:off x="6224037" y="3250000"/>
-            <a:ext cx="2450000" cy="760000"/>
+            <a:off x="6224037" y="2855500"/>
+            <a:ext cx="2450000" cy="1075000"/>
           </a:xfrm>
           <a:prstGeom prst="rect">
             <a:avLst/>
@@ -18766,7 +18766,7 @@
         </p:nvSpPr>
         <p:spPr>
           <a:xfrm>
-            <a:off x="433000" y="4170000"/>
+            <a:off x="433000" y="4210000"/>
             <a:ext cx="8300000" cy="340000"/>
           </a:xfrm>
           <a:prstGeom prst="rect">
@@ -18816,7 +18816,7 @@
         </p:nvSpPr>
         <p:spPr>
           <a:xfrm>
-            <a:off x="341850" y="4510000"/>
+            <a:off x="341850" y="4520000"/>
             <a:ext cx="8400000" cy="330000"/>
           </a:xfrm>
           <a:prstGeom prst="rect">
@@ -18927,7 +18927,7 @@
         <p:spPr>
           <a:xfrm>
             <a:off x="669775" y="1850750"/>
-            <a:ext cx="4000000" cy="1300000"/>
+            <a:ext cx="3700000" cy="1300000"/>
           </a:xfrm>
           <a:prstGeom prst="rect">
             <a:avLst/>
@@ -18946,7 +18946,7 @@
               <a:buNone/>
             </a:pPr>
             <a:r>
-              <a:rPr lang="en" sz="1300" b="1">
+              <a:rPr lang="en" sz="1600" b="1">
                 <a:solidFill>
                   <a:schemeClr val="dk1"/>
                 </a:solidFill>
@@ -18962,7 +18962,7 @@
               <a:buNone/>
             </a:pPr>
             <a:r>
-              <a:rPr lang="en" sz="1200">
+              <a:rPr lang="en" sz="1400">
                 <a:solidFill>
                   <a:schemeClr val="dk1"/>
                 </a:solidFill>

</xml_diff>

<commit_message>
Add pictures to presentation slides
</commit_message>
<xml_diff>
--- a/docs/presentation/verdant-presentation.pptx
+++ b/docs/presentation/verdant-presentation.pptx
@@ -17551,8 +17551,8 @@
         </p:nvSpPr>
         <p:spPr>
           <a:xfrm>
-            <a:off x="341850" y="3100000"/>
-            <a:ext cx="8400000" cy="450000"/>
+            <a:off x="341850" y="3050000"/>
+            <a:ext cx="5800000" cy="650000"/>
           </a:xfrm>
           <a:prstGeom prst="rect">
             <a:avLst/>
@@ -17594,8 +17594,8 @@
         </p:nvSpPr>
         <p:spPr>
           <a:xfrm>
-            <a:off x="341850" y="3700000"/>
-            <a:ext cx="8400000" cy="400000"/>
+            <a:off x="341850" y="3800000"/>
+            <a:ext cx="5800000" cy="400000"/>
           </a:xfrm>
           <a:prstGeom prst="rect">
             <a:avLst/>
@@ -17629,6 +17629,58 @@
           </a:p>
         </p:txBody>
       </p:sp>
+      <p:pic>
+        <p:nvPicPr>
+          <p:cNvPr id="910" name="Window bar" descr=""/>
+          <p:cNvPicPr>
+            <a:picLocks noChangeAspect="1"/>
+          </p:cNvPicPr>
+          <p:nvPr/>
+        </p:nvPicPr>
+        <p:blipFill>
+          <a:blip r:embed="rId3"/>
+          <a:srcRect l="66804"/>
+          <a:stretch/>
+        </p:blipFill>
+        <p:spPr>
+          <a:xfrm>
+            <a:off x="6338700" y="3050000"/>
+            <a:ext cx="2472600" cy="265500"/>
+          </a:xfrm>
+          <a:prstGeom prst="rect">
+            <a:avLst/>
+          </a:prstGeom>
+        </p:spPr>
+      </p:pic>
+      <p:pic>
+        <p:nvPicPr>
+          <p:cNvPr id="911" name="Picture" descr="Turquoise lake water under a clear sky, a stand-in for the open water the bloom figures describe"/>
+          <p:cNvPicPr>
+            <a:picLocks noChangeAspect="1"/>
+          </p:cNvPicPr>
+          <p:nvPr/>
+        </p:nvPicPr>
+        <p:blipFill>
+          <a:blip r:embed="rId4"/>
+          <a:stretch>
+            <a:fillRect/>
+          </a:stretch>
+        </p:blipFill>
+        <p:spPr>
+          <a:xfrm>
+            <a:off x="6350000" y="3315500"/>
+            <a:ext cx="2450000" cy="1300000"/>
+          </a:xfrm>
+          <a:prstGeom prst="rect">
+            <a:avLst/>
+          </a:prstGeom>
+          <a:ln w="9525">
+            <a:solidFill>
+              <a:srgbClr val="707070"/>
+            </a:solidFill>
+          </a:ln>
+        </p:spPr>
+      </p:pic>
     </p:spTree>
   </p:cSld>
   <p:clrMapOvr>
@@ -17703,7 +17755,7 @@
         <p:spPr>
           <a:xfrm>
             <a:off x="341850" y="1700000"/>
-            <a:ext cx="8400000" cy="1250000"/>
+            <a:ext cx="5500000" cy="1250000"/>
           </a:xfrm>
           <a:prstGeom prst="rect">
             <a:avLst/>
@@ -17787,13 +17839,13 @@
         </p:nvPicPr>
         <p:blipFill>
           <a:blip r:embed="rId3"/>
-          <a:srcRect l="70464"/>
+          <a:srcRect l="80533"/>
           <a:stretch/>
         </p:blipFill>
         <p:spPr>
           <a:xfrm>
-            <a:off x="550000" y="3150000"/>
-            <a:ext cx="2200000" cy="265500"/>
+            <a:off x="450000" y="3150000"/>
+            <a:ext cx="1450000" cy="265500"/>
           </a:xfrm>
           <a:prstGeom prst="rect">
             <a:avLst/>
@@ -17808,8 +17860,8 @@
         </p:nvSpPr>
         <p:spPr>
           <a:xfrm>
-            <a:off x="550000" y="3415500"/>
-            <a:ext cx="2200000" cy="800000"/>
+            <a:off x="450000" y="3415500"/>
+            <a:ext cx="1450000" cy="800000"/>
           </a:xfrm>
           <a:prstGeom prst="rect">
             <a:avLst/>
@@ -17860,13 +17912,13 @@
         </p:nvPicPr>
         <p:blipFill>
           <a:blip r:embed="rId3"/>
-          <a:srcRect l="70464"/>
+          <a:srcRect l="80533"/>
           <a:stretch/>
         </p:blipFill>
         <p:spPr>
           <a:xfrm>
-            <a:off x="3600000" y="3150000"/>
-            <a:ext cx="2200000" cy="265500"/>
+            <a:off x="2450000" y="3150000"/>
+            <a:ext cx="1450000" cy="265500"/>
           </a:xfrm>
           <a:prstGeom prst="rect">
             <a:avLst/>
@@ -17881,8 +17933,8 @@
         </p:nvSpPr>
         <p:spPr>
           <a:xfrm>
-            <a:off x="3600000" y="3415500"/>
-            <a:ext cx="2200000" cy="800000"/>
+            <a:off x="2450000" y="3415500"/>
+            <a:ext cx="1450000" cy="800000"/>
           </a:xfrm>
           <a:prstGeom prst="rect">
             <a:avLst/>
@@ -17933,13 +17985,13 @@
         </p:nvPicPr>
         <p:blipFill>
           <a:blip r:embed="rId3"/>
-          <a:srcRect l="70464"/>
+          <a:srcRect l="80533"/>
           <a:stretch/>
         </p:blipFill>
         <p:spPr>
           <a:xfrm>
-            <a:off x="6650000" y="3150000"/>
-            <a:ext cx="2200000" cy="265500"/>
+            <a:off x="4450000" y="3150000"/>
+            <a:ext cx="1450000" cy="265500"/>
           </a:xfrm>
           <a:prstGeom prst="rect">
             <a:avLst/>
@@ -17954,8 +18006,8 @@
         </p:nvSpPr>
         <p:spPr>
           <a:xfrm>
-            <a:off x="6650000" y="3415500"/>
-            <a:ext cx="2200000" cy="800000"/>
+            <a:off x="4450000" y="3415500"/>
+            <a:ext cx="1450000" cy="800000"/>
           </a:xfrm>
           <a:prstGeom prst="rect">
             <a:avLst/>
@@ -18004,8 +18056,8 @@
         </p:nvSpPr>
         <p:spPr>
           <a:xfrm>
-            <a:off x="2750000" y="3415500"/>
-            <a:ext cx="850000" cy="800000"/>
+            <a:off x="1900000" y="3415500"/>
+            <a:ext cx="550000" cy="800000"/>
           </a:xfrm>
           <a:prstGeom prst="rect">
             <a:avLst/>
@@ -18047,8 +18099,8 @@
         </p:nvSpPr>
         <p:spPr>
           <a:xfrm>
-            <a:off x="5800000" y="3415500"/>
-            <a:ext cx="850000" cy="800000"/>
+            <a:off x="3900000" y="3415500"/>
+            <a:ext cx="550000" cy="800000"/>
           </a:xfrm>
           <a:prstGeom prst="rect">
             <a:avLst/>
@@ -18082,6 +18134,58 @@
           </a:p>
         </p:txBody>
       </p:sp>
+      <p:pic>
+        <p:nvPicPr>
+          <p:cNvPr id="910" name="Window bar" descr=""/>
+          <p:cNvPicPr>
+            <a:picLocks noChangeAspect="1"/>
+          </p:cNvPicPr>
+          <p:nvPr/>
+        </p:nvPicPr>
+        <p:blipFill>
+          <a:blip r:embed="rId3"/>
+          <a:srcRect l="66133"/>
+          <a:stretch/>
+        </p:blipFill>
+        <p:spPr>
+          <a:xfrm>
+            <a:off x="6288700" y="1750000"/>
+            <a:ext cx="2522600" cy="265500"/>
+          </a:xfrm>
+          <a:prstGeom prst="rect">
+            <a:avLst/>
+          </a:prstGeom>
+        </p:spPr>
+      </p:pic>
+      <p:pic>
+        <p:nvPicPr>
+          <p:cNvPr id="911" name="Picture" descr="Report form guide titled Is it a bloom, with drawings of what looks like a bloom and what is often mistaken for one"/>
+          <p:cNvPicPr>
+            <a:picLocks noChangeAspect="1"/>
+          </p:cNvPicPr>
+          <p:nvPr/>
+        </p:nvPicPr>
+        <p:blipFill>
+          <a:blip r:embed="rId4"/>
+          <a:stretch>
+            <a:fillRect/>
+          </a:stretch>
+        </p:blipFill>
+        <p:spPr>
+          <a:xfrm>
+            <a:off x="6300000" y="2015500"/>
+            <a:ext cx="2500000" cy="1639344"/>
+          </a:xfrm>
+          <a:prstGeom prst="rect">
+            <a:avLst/>
+          </a:prstGeom>
+          <a:ln w="9525">
+            <a:solidFill>
+              <a:srgbClr val="707070"/>
+            </a:solidFill>
+          </a:ln>
+        </p:spPr>
+      </p:pic>
     </p:spTree>
   </p:cSld>
   <p:clrMapOvr>
@@ -18109,7 +18213,7 @@
       </p:grpSpPr>
       <p:pic>
         <p:nvPicPr>
-          <p:cNvPr id="259" name="Google Shape;259;p32" title="beautiful-sea-life-with-aquatic-animal (1).jpg"/>
+          <p:cNvPr id="259" name="Google Shape;259;p32" descr="Verdant sampling priority list ranking Callville Bay first, with its very high risk score and recommended sampling target"/>
           <p:cNvPicPr preferRelativeResize="0"/>
           <p:nvPr>
             <p:ph idx="3" type="pic"/>
@@ -18119,13 +18223,13 @@
           <a:blip r:embed="rId3">
             <a:alphaModFix/>
           </a:blip>
-          <a:srcRect b="0" l="20934" r="20934" t="0"/>
+          <a:srcRect/>
           <a:stretch/>
         </p:blipFill>
         <p:spPr>
-          <a:xfrm flipH="1">
-            <a:off x="6386650" y="947025"/>
-            <a:ext cx="2107500" cy="2067599"/>
+          <a:xfrm>
+            <a:off x="6250000" y="1212525"/>
+            <a:ext cx="2500000" cy="1842105"/>
           </a:xfrm>
           <a:prstGeom prst="rect">
             <a:avLst/>
@@ -18236,10 +18340,10 @@
         </p:nvGrpSpPr>
         <p:grpSpPr>
           <a:xfrm>
-            <a:off x="6386650" y="947025"/>
-            <a:ext cx="2107351" cy="265500"/>
-            <a:chOff x="6386650" y="947025"/>
-            <a:chExt cx="2107351" cy="265500"/>
+            <a:off x="6250000" y="947025"/>
+            <a:ext cx="2500000" cy="265500"/>
+            <a:chOff x="6250000" y="947025"/>
+            <a:chExt cx="2500000" cy="265500"/>
           </a:xfrm>
         </p:grpSpPr>
         <p:pic>
@@ -18252,13 +18356,13 @@
             <a:blip r:embed="rId4">
               <a:alphaModFix/>
             </a:blip>
-            <a:srcRect b="0" l="71707" r="0" t="0"/>
+            <a:srcRect b="0" l="66436" r="0" t="0"/>
             <a:stretch/>
           </p:blipFill>
           <p:spPr>
             <a:xfrm>
-              <a:off x="6386650" y="947025"/>
-              <a:ext cx="2107351" cy="265500"/>
+              <a:off x="6250000" y="947025"/>
+              <a:ext cx="2500000" cy="265500"/>
             </a:xfrm>
             <a:prstGeom prst="rect">
               <a:avLst/>
@@ -18279,13 +18383,13 @@
             <a:blip r:embed="rId4">
               <a:alphaModFix/>
             </a:blip>
-            <a:srcRect b="0" l="71707" r="0" t="0"/>
+            <a:srcRect b="0" l="66436" r="0" t="0"/>
             <a:stretch/>
           </p:blipFill>
           <p:spPr>
             <a:xfrm>
-              <a:off x="6386650" y="947025"/>
-              <a:ext cx="2107351" cy="265500"/>
+              <a:off x="6250000" y="947025"/>
+              <a:ext cx="2500000" cy="265500"/>
             </a:xfrm>
             <a:prstGeom prst="rect">
               <a:avLst/>
@@ -18612,13 +18716,13 @@
         </p:nvPicPr>
         <p:blipFill>
           <a:blip r:embed="rId3"/>
-          <a:srcRect l="66804"/>
+          <a:srcRect l="64119"/>
           <a:stretch/>
         </p:blipFill>
         <p:spPr>
           <a:xfrm>
             <a:off x="422861" y="2590000"/>
-            <a:ext cx="2472600" cy="265500"/>
+            <a:ext cx="2672600" cy="265500"/>
           </a:xfrm>
           <a:prstGeom prst="rect">
             <a:avLst/>
@@ -18642,7 +18746,7 @@
         <p:spPr>
           <a:xfrm>
             <a:off x="434161" y="2855500"/>
-            <a:ext cx="2450000" cy="1075000"/>
+            <a:ext cx="2650000" cy="1300000"/>
           </a:xfrm>
           <a:prstGeom prst="rect">
             <a:avLst/>
@@ -18664,13 +18768,13 @@
         </p:nvPicPr>
         <p:blipFill>
           <a:blip r:embed="rId3"/>
-          <a:srcRect l="66804"/>
+          <a:srcRect l="64119"/>
           <a:stretch/>
         </p:blipFill>
         <p:spPr>
           <a:xfrm>
             <a:off x="3320073" y="2590000"/>
-            <a:ext cx="2472600" cy="265500"/>
+            <a:ext cx="2672600" cy="265500"/>
           </a:xfrm>
           <a:prstGeom prst="rect">
             <a:avLst/>
@@ -18694,7 +18798,7 @@
         <p:spPr>
           <a:xfrm>
             <a:off x="3331373" y="2855500"/>
-            <a:ext cx="2450000" cy="1075000"/>
+            <a:ext cx="2650000" cy="1300000"/>
           </a:xfrm>
           <a:prstGeom prst="rect">
             <a:avLst/>
@@ -18716,13 +18820,13 @@
         </p:nvPicPr>
         <p:blipFill>
           <a:blip r:embed="rId3"/>
-          <a:srcRect l="66804"/>
+          <a:srcRect l="64119"/>
           <a:stretch/>
         </p:blipFill>
         <p:spPr>
           <a:xfrm>
             <a:off x="6212737" y="2590000"/>
-            <a:ext cx="2472600" cy="265500"/>
+            <a:ext cx="2672600" cy="265500"/>
           </a:xfrm>
           <a:prstGeom prst="rect">
             <a:avLst/>
@@ -18746,7 +18850,7 @@
         <p:spPr>
           <a:xfrm>
             <a:off x="6224037" y="2855500"/>
-            <a:ext cx="2450000" cy="1075000"/>
+            <a:ext cx="2650000" cy="1300000"/>
           </a:xfrm>
           <a:prstGeom prst="rect">
             <a:avLst/>
@@ -18766,8 +18870,8 @@
         </p:nvSpPr>
         <p:spPr>
           <a:xfrm>
-            <a:off x="433000" y="4210000"/>
-            <a:ext cx="8300000" cy="340000"/>
+            <a:off x="433000" y="4260000"/>
+            <a:ext cx="8300000" cy="280000"/>
           </a:xfrm>
           <a:prstGeom prst="rect">
             <a:avLst/>
@@ -19076,6 +19180,58 @@
           </a:p>
         </p:txBody>
       </p:sp>
+      <p:pic>
+        <p:nvPicPr>
+          <p:cNvPr id="910" name="Window bar" descr=""/>
+          <p:cNvPicPr>
+            <a:picLocks noChangeAspect="1"/>
+          </p:cNvPicPr>
+          <p:nvPr/>
+        </p:nvPicPr>
+        <p:blipFill>
+          <a:blip r:embed="rId3"/>
+          <a:srcRect l="52707"/>
+          <a:stretch/>
+        </p:blipFill>
+        <p:spPr>
+          <a:xfrm>
+            <a:off x="749900" y="3000000"/>
+            <a:ext cx="3522600" cy="265500"/>
+          </a:xfrm>
+          <a:prstGeom prst="rect">
+            <a:avLst/>
+          </a:prstGeom>
+        </p:spPr>
+      </p:pic>
+      <p:pic>
+        <p:nvPicPr>
+          <p:cNvPr id="911" name="Picture" descr="Green rolling hills under a blue sky with clouds"/>
+          <p:cNvPicPr>
+            <a:picLocks noChangeAspect="1"/>
+          </p:cNvPicPr>
+          <p:nvPr/>
+        </p:nvPicPr>
+        <p:blipFill>
+          <a:blip r:embed="rId4"/>
+          <a:stretch>
+            <a:fillRect/>
+          </a:stretch>
+        </p:blipFill>
+        <p:spPr>
+          <a:xfrm>
+            <a:off x="761200" y="3265500"/>
+            <a:ext cx="3500000" cy="1234000"/>
+          </a:xfrm>
+          <a:prstGeom prst="rect">
+            <a:avLst/>
+          </a:prstGeom>
+          <a:ln w="9525">
+            <a:solidFill>
+              <a:srgbClr val="707070"/>
+            </a:solidFill>
+          </a:ln>
+        </p:spPr>
+      </p:pic>
     </p:spTree>
   </p:cSld>
   <p:clrMapOvr>

</xml_diff>

<commit_message>
Align presentation text with the owner's script
</commit_message>
<xml_diff>
--- a/docs/presentation/verdant-presentation.pptx
+++ b/docs/presentation/verdant-presentation.pptx
@@ -970,7 +970,7 @@
           <a:lstStyle/>
           <a:p>
             <a:r>
-              <a:t>Monitoring cannot cover every shoreline continuously. People at the water can help, but an observation may arrive with an unclear location or missing details, or mistake duckweed for a bloom. Without feedback, the reporter also misses a chance to learn whether their observation helped.</a:t>
+              <a:t>Monitoring cannot cover every shoreline continuously. People at the water can help, but an observation may have an unclear location, missing details, or confuse duckweed with a bloom. Without feedback, the reporter also misses a chance to learn whether their observation helped.</a:t>
             </a:r>
           </a:p>
         </p:txBody>
@@ -1059,7 +1059,7 @@
           <a:lstStyle/>
           <a:p>
             <a:r>
-              <a:t>From 2016 through 2018, reports from eighteen U.S. states linked harmful algal blooms to three hundred eighty-nine human illnesses and at least four hundred thirteen animal illnesses, across four hundred twenty-one reported bloom events. Blooms connect environmental, human, and animal health.</a:t>
+              <a:t>From 2016 through 2018, reports from eighteen U.S. states linked harmful algal blooms to three hundred eighty-nine human illnesses and at least four hundred thirteen animal illnesses, across four hundred twenty-one reported bloom events. This connects environmental, human, and animal health.</a:t>
             </a:r>
           </a:p>
         </p:txBody>
@@ -17581,7 +17581,7 @@
                 <a:cs typeface="Roboto Mono"/>
                 <a:sym typeface="Roboto Mono"/>
               </a:rPr>
-              <a:t>18 U.S. states · 2016-2018 · National figures, not Lake Mead-specific</a:t>
+              <a:t>18 U.S. states · 2016–2018 · National figures, not Lake Mead-specific</a:t>
             </a:r>
           </a:p>
         </p:txBody>
@@ -17624,7 +17624,7 @@
                 <a:cs typeface="Roboto Mono"/>
                 <a:sym typeface="Roboto Mono"/>
               </a:rPr>
-              <a:t>Source: CDC, MMWR 69(50), December 18, 2020</a:t>
+              <a:t>Source: CDC, MMWR 69(50), December 18, 2020.</a:t>
             </a:r>
           </a:p>
         </p:txBody>
@@ -18950,7 +18950,7 @@
                 <a:cs typeface="Roboto Mono"/>
                 <a:sym typeface="Roboto Mono"/>
               </a:rPr>
-              <a:t>Prototype: scores unvalidated; ranger outcomes simulated</a:t>
+              <a:t>Prototype — scores unvalidated; ranger outcomes simulated</a:t>
             </a:r>
           </a:p>
         </p:txBody>
@@ -19055,7 +19055,7 @@
                   <a:schemeClr val="dk1"/>
                 </a:solidFill>
               </a:rPr>
-              <a:t>See the bloom before it becomes a warning</a:t>
+              <a:t>See the bloom before it becomes a warning.</a:t>
             </a:r>
           </a:p>
           <a:p>

</xml_diff>

<commit_message>
Reduce the deck to four slides that follow the revised script
</commit_message>
<xml_diff>
--- a/docs/presentation/verdant-presentation.pptx
+++ b/docs/presentation/verdant-presentation.pptx
@@ -10,7 +10,6 @@
   </p:notesMasterIdLst>
   <p:sldIdLst>
     <p:sldId id="263" r:id="rId14"/>
-    <p:sldId id="262" r:id="rId13"/>
     <p:sldId id="260" r:id="rId11"/>
     <p:sldId id="264" r:id="rId15"/>
     <p:sldId id="269" r:id="rId20"/>
@@ -792,7 +791,8 @@
           <a:lstStyle/>
           <a:p>
             <a:r>
-              <a:t>Verdant helps people contribute and helps experts decide where to look first. See the bloom before it becomes a warning.</a:t>
+              <a:rPr lang="en"/>
+              <a:t>Verdant turns a shoreline observation into a visible path toward review and action, helping communities contribute and experts decide where to look first.</a:t>
             </a:r>
           </a:p>
         </p:txBody>
@@ -881,96 +881,8 @@
           <a:lstStyle/>
           <a:p>
             <a:r>
-              <a:t>Verdant connects guided citizen reporting, explainable site scores, and ranger review. Let's follow one observation at our Lake Mead pilot.</a:t>
-            </a:r>
-          </a:p>
-        </p:txBody>
-      </p:sp>
-    </p:spTree>
-  </p:cSld>
-  <p:clrMapOvr>
-    <a:masterClrMapping/>
-  </p:clrMapOvr>
-</p:notes>
-</file>
-
-<file path=ppt/notesSlides/notesSlide7.xml><?xml version="1.0" encoding="utf-8"?>
-<p:notes xmlns:a="http://schemas.openxmlformats.org/drawingml/2006/main" xmlns:r="http://schemas.openxmlformats.org/officeDocument/2006/relationships" xmlns:mc="http://schemas.openxmlformats.org/markup-compatibility/2006" xmlns:mv="urn:schemas-microsoft-com:mac:vml" xmlns:p="http://schemas.openxmlformats.org/presentationml/2006/main" xmlns:c="http://schemas.openxmlformats.org/drawingml/2006/chart" xmlns:dgm="http://schemas.openxmlformats.org/drawingml/2006/diagram" xmlns:o="urn:schemas-microsoft-com:office:office" xmlns:v="urn:schemas-microsoft-com:vml" xmlns:pvml="urn:schemas-microsoft-com:office:powerpoint" xmlns:com="http://schemas.openxmlformats.org/drawingml/2006/compatibility" xmlns:p14="http://schemas.microsoft.com/office/powerpoint/2010/main" xmlns:p15="http://schemas.microsoft.com/office/powerpoint/2012/main" xmlns:ahyp="http://schemas.microsoft.com/office/drawing/2018/hyperlinkcolor" showMasterPhAnim="0" showMasterSp="0">
-  <p:cSld>
-    <p:spTree>
-      <p:nvGrpSpPr>
-        <p:cNvPr id="272" name="Shape 272"/>
-        <p:cNvGrpSpPr/>
-        <p:nvPr/>
-      </p:nvGrpSpPr>
-      <p:grpSpPr>
-        <a:xfrm>
-          <a:off x="0" y="0"/>
-          <a:ext cx="0" cy="0"/>
-          <a:chOff x="0" y="0"/>
-          <a:chExt cx="0" cy="0"/>
-        </a:xfrm>
-      </p:grpSpPr>
-      <p:sp>
-        <p:nvSpPr>
-          <p:cNvPr id="273" name="Google Shape;273;ge1d838b627_4_38:notes"/>
-          <p:cNvSpPr/>
-          <p:nvPr>
-            <p:ph idx="2" type="sldImg"/>
-          </p:nvPr>
-        </p:nvSpPr>
-        <p:spPr>
-          <a:xfrm>
-            <a:off x="381300" y="685800"/>
-            <a:ext cx="6096000" cy="3429000"/>
-          </a:xfrm>
-          <a:custGeom>
-            <a:rect b="b" l="l" r="r" t="t"/>
-            <a:pathLst>
-              <a:path extrusionOk="0" h="120000" w="120000">
-                <a:moveTo>
-                  <a:pt x="0" y="0"/>
-                </a:moveTo>
-                <a:lnTo>
-                  <a:pt x="120000" y="0"/>
-                </a:lnTo>
-                <a:lnTo>
-                  <a:pt x="120000" y="120000"/>
-                </a:lnTo>
-                <a:lnTo>
-                  <a:pt x="0" y="120000"/>
-                </a:lnTo>
-                <a:close/>
-              </a:path>
-            </a:pathLst>
-          </a:custGeom>
-        </p:spPr>
-      </p:sp>
-      <p:sp>
-        <p:nvSpPr>
-          <p:cNvPr id="274" name="Google Shape;274;ge1d838b627_4_38:notes"/>
-          <p:cNvSpPr txBox="1"/>
-          <p:nvPr>
-            <p:ph idx="1" type="body"/>
-          </p:nvPr>
-        </p:nvSpPr>
-        <p:spPr>
-          <a:xfrm>
-            <a:off x="685800" y="4343400"/>
-            <a:ext cx="5486400" cy="4114800"/>
-          </a:xfrm>
-          <a:prstGeom prst="rect">
-            <a:avLst/>
-          </a:prstGeom>
-        </p:spPr>
-        <p:txBody>
-          <a:bodyPr anchorCtr="0" anchor="t" bIns="91425" lIns="91425" spcFirstLastPara="1" rIns="91425" wrap="square" tIns="91425">
-            <a:noAutofit/>
-          </a:bodyPr>
-          <a:lstStyle/>
-          <a:p>
-            <a:r>
-              <a:t>Monitoring cannot cover every shoreline continuously. People at the water can help, but an observation may have an unclear location, missing details, or confuse duckweed with a bloom. Without feedback, the reporter also misses a chance to learn whether their observation helped.</a:t>
+              <a:rPr lang="en"/>
+              <a:t>Typically rangers rely on citizen reports to address these issues, though a report may lack detail, confuse a bloom with a look-alike, or leave the reporter without feedback. Verdant connects guided reporting, ranger review, and explainable sampling priorities. We used Lake Mead as a pilot to demonstrate the workflow; we used Coimbra to show its application to a OneAquaHealth case-study city and its scalability to other locations</a:t>
             </a:r>
           </a:p>
         </p:txBody>
@@ -1059,7 +971,8 @@
           <a:lstStyle/>
           <a:p>
             <a:r>
-              <a:t>From 2016 through 2018, reports from eighteen U.S. states linked harmful algal blooms to three hundred eighty-nine human illnesses and at least four hundred thirteen animal illnesses, across four hundred twenty-one reported bloom events. This connects environmental, human, and animal health.</a:t>
+              <a:rPr lang="en"/>
+              <a:t>Water ecosystem health connects people, animals, and the environment. From 2016 to 2018, eighteen U.S. states reported four hundred twenty-one harmful algal bloom events, associated with hundreds of human and animal illnesses. Monitoring and useful citizen observations are both part of the response.</a:t>
             </a:r>
           </a:p>
         </p:txBody>
@@ -1148,7 +1061,8 @@
           <a:lstStyle/>
           <a:p>
             <a:r>
-              <a:t>The intended impact is more useful citizen observations, clearer sampling priorities, and feedback that encourages participation. That supports One Health by connecting environmental conditions with human and animal exposure. Today, this is a browser-based prototype with unvalidated scores. Next, we need field validation, shared reporting infrastructure, and operational data partnerships.</a:t>
+              <a:rPr lang="en"/>
+              <a:t>Today, our prototype demonstrates the interface, scoring logic, and reporting loop. Reports stay in one browser, but this is not a shared citizen-and-ranger service yet. Our next steps are a shared backend, authenticated ranger roles, and duplicate-report controls, alongside field validation and usability testing. We would measure reporting completion, usefulness to rangers, and agreement with field results before claiming better monitoring outcomes.</a:t>
             </a:r>
           </a:p>
         </p:txBody>
@@ -17293,12 +17207,12 @@
               <a:buNone/>
             </a:pPr>
             <a:r>
-              <a:rPr lang="en">
+              <a:rPr lang="en" sz="2400">
                 <a:solidFill>
                   <a:schemeClr val="dk1"/>
                 </a:solidFill>
               </a:rPr>
-              <a:t>Verdant: why this matters</a:t>
+              <a:t>Healthier water starts with better observations.</a:t>
             </a:r>
           </a:p>
         </p:txBody>
@@ -17313,8 +17227,8 @@
         </p:nvSpPr>
         <p:spPr>
           <a:xfrm>
-            <a:off x="3145041" y="2250000"/>
-            <a:ext cx="2599200" cy="600000"/>
+            <a:off x="3145041" y="2500000"/>
+            <a:ext cx="2599200" cy="450000"/>
           </a:xfrm>
           <a:prstGeom prst="rect">
             <a:avLst/>
@@ -17353,8 +17267,8 @@
         </p:nvSpPr>
         <p:spPr>
           <a:xfrm>
-            <a:off x="341850" y="2250000"/>
-            <a:ext cx="2599200" cy="600000"/>
+            <a:off x="341850" y="2500000"/>
+            <a:ext cx="2599200" cy="450000"/>
           </a:xfrm>
           <a:prstGeom prst="rect">
             <a:avLst/>
@@ -17378,7 +17292,7 @@
                   <a:schemeClr val="dk1"/>
                 </a:solidFill>
               </a:rPr>
-              <a:t>reported harmful algal bloom events</a:t>
+              <a:t>bloom events</a:t>
             </a:r>
           </a:p>
         </p:txBody>
@@ -17393,8 +17307,8 @@
         </p:nvSpPr>
         <p:spPr>
           <a:xfrm>
-            <a:off x="5948257" y="2250000"/>
-            <a:ext cx="2599200" cy="600000"/>
+            <a:off x="5948257" y="2500000"/>
+            <a:ext cx="2599200" cy="450000"/>
           </a:xfrm>
           <a:prstGeom prst="rect">
             <a:avLst/>
@@ -17433,7 +17347,7 @@
         </p:nvSpPr>
         <p:spPr>
           <a:xfrm>
-            <a:off x="3145041" y="1350000"/>
+            <a:off x="3145041" y="1650000"/>
             <a:ext cx="2599200" cy="850000"/>
           </a:xfrm>
           <a:prstGeom prst="rect">
@@ -17473,7 +17387,7 @@
         </p:nvSpPr>
         <p:spPr>
           <a:xfrm>
-            <a:off x="341850" y="1350000"/>
+            <a:off x="341850" y="1650000"/>
             <a:ext cx="2599200" cy="850000"/>
           </a:xfrm>
           <a:prstGeom prst="rect">
@@ -17513,7 +17427,7 @@
         </p:nvSpPr>
         <p:spPr>
           <a:xfrm>
-            <a:off x="5948257" y="1350000"/>
+            <a:off x="5948257" y="1650000"/>
             <a:ext cx="2599200" cy="850000"/>
           </a:xfrm>
           <a:prstGeom prst="rect">
@@ -17551,8 +17465,8 @@
         </p:nvSpPr>
         <p:spPr>
           <a:xfrm>
-            <a:off x="341850" y="3050000"/>
-            <a:ext cx="5800000" cy="650000"/>
+            <a:off x="341850" y="3100000"/>
+            <a:ext cx="5800000" cy="450000"/>
           </a:xfrm>
           <a:prstGeom prst="rect">
             <a:avLst/>
@@ -17581,7 +17495,7 @@
                 <a:cs typeface="Roboto Mono"/>
                 <a:sym typeface="Roboto Mono"/>
               </a:rPr>
-              <a:t>18 U.S. states · 2016–2018 · National figures, not Lake Mead-specific</a:t>
+              <a:t>18 U.S. states, 2016–2018 — not Lake Mead-specific</a:t>
             </a:r>
           </a:p>
         </p:txBody>
@@ -17594,7 +17508,7 @@
         </p:nvSpPr>
         <p:spPr>
           <a:xfrm>
-            <a:off x="341850" y="3800000"/>
+            <a:off x="341850" y="3600000"/>
             <a:ext cx="5800000" cy="400000"/>
           </a:xfrm>
           <a:prstGeom prst="rect">
@@ -17624,7 +17538,50 @@
                 <a:cs typeface="Roboto Mono"/>
                 <a:sym typeface="Roboto Mono"/>
               </a:rPr>
-              <a:t>Source: CDC, MMWR 69(50), December 18, 2020.</a:t>
+              <a:t>Source: CDC, MMWR 69(50), December 18, 2020</a:t>
+            </a:r>
+          </a:p>
+        </p:txBody>
+      </p:sp>
+      <p:sp>
+        <p:nvSpPr>
+          <p:cNvPr id="903" name="Text"/>
+          <p:cNvSpPr txBox="1"/>
+          <p:nvPr/>
+        </p:nvSpPr>
+        <p:spPr>
+          <a:xfrm>
+            <a:off x="341850" y="1230000"/>
+            <a:ext cx="8249700" cy="400000"/>
+          </a:xfrm>
+          <a:prstGeom prst="rect">
+            <a:avLst/>
+          </a:prstGeom>
+          <a:noFill/>
+        </p:spPr>
+        <p:txBody>
+          <a:bodyPr wrap="square" lIns="91425" tIns="91425" rIns="91425" bIns="91425" anchor="t">
+            <a:noAutofit/>
+          </a:bodyPr>
+          <a:lstStyle/>
+          <a:p>
+            <a:pPr marL="0" indent="0" algn="l">
+              <a:spcBef>
+                <a:spcPts val="0"/>
+              </a:spcBef>
+              <a:buNone/>
+            </a:pPr>
+            <a:r>
+              <a:rPr lang="en" sz="1600" b="1">
+                <a:solidFill>
+                  <a:schemeClr val="dk1"/>
+                </a:solidFill>
+                <a:latin typeface="Roboto Mono"/>
+                <a:ea typeface="Roboto Mono"/>
+                <a:cs typeface="Roboto Mono"/>
+                <a:sym typeface="Roboto Mono"/>
+              </a:rPr>
+              <a:t>Environment · People · Animals</a:t>
             </a:r>
           </a:p>
         </p:txBody>
@@ -17644,7 +17601,7 @@
         </p:blipFill>
         <p:spPr>
           <a:xfrm>
-            <a:off x="6338700" y="3050000"/>
+            <a:off x="6338700" y="3150000"/>
             <a:ext cx="2472600" cy="265500"/>
           </a:xfrm>
           <a:prstGeom prst="rect">
@@ -17668,513 +17625,8 @@
         </p:blipFill>
         <p:spPr>
           <a:xfrm>
-            <a:off x="6350000" y="3315500"/>
+            <a:off x="6350000" y="3415500"/>
             <a:ext cx="2450000" cy="1300000"/>
-          </a:xfrm>
-          <a:prstGeom prst="rect">
-            <a:avLst/>
-          </a:prstGeom>
-          <a:ln w="9525">
-            <a:solidFill>
-              <a:srgbClr val="707070"/>
-            </a:solidFill>
-          </a:ln>
-        </p:spPr>
-      </p:pic>
-    </p:spTree>
-  </p:cSld>
-  <p:clrMapOvr>
-    <a:masterClrMapping/>
-  </p:clrMapOvr>
-</p:sld>
-</file>
-
-<file path=ppt/slides/slide2.xml><?xml version="1.0" encoding="utf-8"?>
-<p:sld xmlns:a="http://schemas.openxmlformats.org/drawingml/2006/main" xmlns:r="http://schemas.openxmlformats.org/officeDocument/2006/relationships" xmlns:mc="http://schemas.openxmlformats.org/markup-compatibility/2006" xmlns:mv="urn:schemas-microsoft-com:mac:vml" xmlns:p="http://schemas.openxmlformats.org/presentationml/2006/main" xmlns:c="http://schemas.openxmlformats.org/drawingml/2006/chart" xmlns:dgm="http://schemas.openxmlformats.org/drawingml/2006/diagram" xmlns:o="urn:schemas-microsoft-com:office:office" xmlns:v="urn:schemas-microsoft-com:vml" xmlns:pvml="urn:schemas-microsoft-com:office:powerpoint" xmlns:com="http://schemas.openxmlformats.org/drawingml/2006/compatibility" xmlns:p14="http://schemas.microsoft.com/office/powerpoint/2010/main" xmlns:p15="http://schemas.microsoft.com/office/powerpoint/2012/main" xmlns:ahyp="http://schemas.microsoft.com/office/drawing/2018/hyperlinkcolor">
-  <p:cSld>
-    <p:spTree>
-      <p:nvGrpSpPr>
-        <p:cNvPr id="275" name="Shape 275"/>
-        <p:cNvGrpSpPr/>
-        <p:nvPr/>
-      </p:nvGrpSpPr>
-      <p:grpSpPr>
-        <a:xfrm>
-          <a:off x="0" y="0"/>
-          <a:ext cx="0" cy="0"/>
-          <a:chOff x="0" y="0"/>
-          <a:chExt cx="0" cy="0"/>
-        </a:xfrm>
-      </p:grpSpPr>
-      <p:sp>
-        <p:nvSpPr>
-          <p:cNvPr id="276" name="Google Shape;276;p34"/>
-          <p:cNvSpPr txBox="1"/>
-          <p:nvPr>
-            <p:ph type="title"/>
-          </p:nvPr>
-        </p:nvSpPr>
-        <p:spPr>
-          <a:xfrm>
-            <a:off x="341850" y="654800"/>
-            <a:ext cx="8573700" cy="1000000"/>
-          </a:xfrm>
-          <a:prstGeom prst="rect">
-            <a:avLst/>
-          </a:prstGeom>
-        </p:spPr>
-        <p:txBody>
-          <a:bodyPr anchorCtr="0" anchor="t" bIns="91425" lIns="91425" spcFirstLastPara="1" rIns="91425" wrap="square" tIns="91425">
-            <a:noAutofit/>
-          </a:bodyPr>
-          <a:lstStyle/>
-          <a:p>
-            <a:pPr marL="0" indent="0" algn="l">
-              <a:spcBef>
-                <a:spcPts val="0"/>
-              </a:spcBef>
-              <a:buNone/>
-            </a:pPr>
-            <a:r>
-              <a:rPr lang="en" sz="2800">
-                <a:solidFill>
-                  <a:schemeClr val="dk1"/>
-                </a:solidFill>
-              </a:rPr>
-              <a:t>People see the water. Rangers need usable evidence.</a:t>
-            </a:r>
-          </a:p>
-        </p:txBody>
-      </p:sp>
-      <p:sp>
-        <p:nvSpPr>
-          <p:cNvPr id="901" name="Text"/>
-          <p:cNvSpPr txBox="1"/>
-          <p:nvPr/>
-        </p:nvSpPr>
-        <p:spPr>
-          <a:xfrm>
-            <a:off x="341850" y="1700000"/>
-            <a:ext cx="5500000" cy="1250000"/>
-          </a:xfrm>
-          <a:prstGeom prst="rect">
-            <a:avLst/>
-          </a:prstGeom>
-          <a:noFill/>
-        </p:spPr>
-        <p:txBody>
-          <a:bodyPr wrap="square" lIns="91425" tIns="91425" rIns="91425" bIns="91425" anchor="t">
-            <a:noAutofit/>
-          </a:bodyPr>
-          <a:lstStyle/>
-          <a:p>
-            <a:pPr marL="241300" indent="-215900" algn="l">
-              <a:spcBef>
-                <a:spcPts val="0"/>
-              </a:spcBef>
-              <a:buClr>
-                <a:schemeClr val="dk1"/>
-              </a:buClr>
-              <a:buSzPts val="1100"/>
-              <a:buChar char="●"/>
-            </a:pPr>
-            <a:r>
-              <a:rPr lang="en" sz="1400">
-                <a:solidFill>
-                  <a:schemeClr val="dk1"/>
-                </a:solidFill>
-              </a:rPr>
-              <a:t>Unclear locations and missing details</a:t>
-            </a:r>
-          </a:p>
-          <a:p>
-            <a:pPr marL="241300" indent="-215900" algn="l">
-              <a:spcBef>
-                <a:spcPts val="500"/>
-              </a:spcBef>
-              <a:buClr>
-                <a:schemeClr val="dk1"/>
-              </a:buClr>
-              <a:buSzPts val="1100"/>
-              <a:buChar char="●"/>
-            </a:pPr>
-            <a:r>
-              <a:rPr lang="en" sz="1400">
-                <a:solidFill>
-                  <a:schemeClr val="dk1"/>
-                </a:solidFill>
-              </a:rPr>
-              <a:t>Blooms confused with look-alikes</a:t>
-            </a:r>
-          </a:p>
-          <a:p>
-            <a:pPr marL="241300" indent="-215900" algn="l">
-              <a:spcBef>
-                <a:spcPts val="500"/>
-              </a:spcBef>
-              <a:buClr>
-                <a:schemeClr val="dk1"/>
-              </a:buClr>
-              <a:buSzPts val="1100"/>
-              <a:buChar char="●"/>
-            </a:pPr>
-            <a:r>
-              <a:rPr lang="en" sz="1400">
-                <a:solidFill>
-                  <a:schemeClr val="dk1"/>
-                </a:solidFill>
-              </a:rPr>
-              <a:t>Reporters need feedback</a:t>
-            </a:r>
-          </a:p>
-        </p:txBody>
-      </p:sp>
-      <p:pic>
-        <p:nvPicPr>
-          <p:cNvPr id="902" name="Window bar" descr=""/>
-          <p:cNvPicPr>
-            <a:picLocks noChangeAspect="1"/>
-          </p:cNvPicPr>
-          <p:nvPr/>
-        </p:nvPicPr>
-        <p:blipFill>
-          <a:blip r:embed="rId3"/>
-          <a:srcRect l="80533"/>
-          <a:stretch/>
-        </p:blipFill>
-        <p:spPr>
-          <a:xfrm>
-            <a:off x="450000" y="3150000"/>
-            <a:ext cx="1450000" cy="265500"/>
-          </a:xfrm>
-          <a:prstGeom prst="rect">
-            <a:avLst/>
-          </a:prstGeom>
-        </p:spPr>
-      </p:pic>
-      <p:sp>
-        <p:nvSpPr>
-          <p:cNvPr id="903" name="Panel"/>
-          <p:cNvSpPr/>
-          <p:nvPr/>
-        </p:nvSpPr>
-        <p:spPr>
-          <a:xfrm>
-            <a:off x="450000" y="3415500"/>
-            <a:ext cx="1450000" cy="800000"/>
-          </a:xfrm>
-          <a:prstGeom prst="rect">
-            <a:avLst/>
-          </a:prstGeom>
-          <a:solidFill>
-            <a:srgbClr val="EFEFEF"/>
-          </a:solidFill>
-          <a:ln w="12700">
-            <a:solidFill>
-              <a:srgbClr val="707070"/>
-            </a:solidFill>
-          </a:ln>
-        </p:spPr>
-        <p:txBody>
-          <a:bodyPr wrap="square" lIns="91425" tIns="45720" rIns="91425" bIns="45720" anchor="ctr">
-            <a:noAutofit/>
-          </a:bodyPr>
-          <a:lstStyle/>
-          <a:p>
-            <a:pPr marL="0" indent="0" algn="ctr">
-              <a:spcBef>
-                <a:spcPts val="0"/>
-              </a:spcBef>
-              <a:buNone/>
-            </a:pPr>
-            <a:r>
-              <a:rPr lang="en" sz="1400">
-                <a:solidFill>
-                  <a:schemeClr val="dk1"/>
-                </a:solidFill>
-                <a:latin typeface="Roboto Mono"/>
-                <a:ea typeface="Roboto Mono"/>
-                <a:cs typeface="Roboto Mono"/>
-                <a:sym typeface="Roboto Mono"/>
-              </a:rPr>
-              <a:t>Shore observation</a:t>
-            </a:r>
-          </a:p>
-        </p:txBody>
-      </p:sp>
-      <p:pic>
-        <p:nvPicPr>
-          <p:cNvPr id="904" name="Window bar" descr=""/>
-          <p:cNvPicPr>
-            <a:picLocks noChangeAspect="1"/>
-          </p:cNvPicPr>
-          <p:nvPr/>
-        </p:nvPicPr>
-        <p:blipFill>
-          <a:blip r:embed="rId3"/>
-          <a:srcRect l="80533"/>
-          <a:stretch/>
-        </p:blipFill>
-        <p:spPr>
-          <a:xfrm>
-            <a:off x="2450000" y="3150000"/>
-            <a:ext cx="1450000" cy="265500"/>
-          </a:xfrm>
-          <a:prstGeom prst="rect">
-            <a:avLst/>
-          </a:prstGeom>
-        </p:spPr>
-      </p:pic>
-      <p:sp>
-        <p:nvSpPr>
-          <p:cNvPr id="905" name="Panel"/>
-          <p:cNvSpPr/>
-          <p:nvPr/>
-        </p:nvSpPr>
-        <p:spPr>
-          <a:xfrm>
-            <a:off x="2450000" y="3415500"/>
-            <a:ext cx="1450000" cy="800000"/>
-          </a:xfrm>
-          <a:prstGeom prst="rect">
-            <a:avLst/>
-          </a:prstGeom>
-          <a:solidFill>
-            <a:srgbClr val="EFEFEF"/>
-          </a:solidFill>
-          <a:ln w="12700">
-            <a:solidFill>
-              <a:srgbClr val="707070"/>
-            </a:solidFill>
-          </a:ln>
-        </p:spPr>
-        <p:txBody>
-          <a:bodyPr wrap="square" lIns="91425" tIns="45720" rIns="91425" bIns="45720" anchor="ctr">
-            <a:noAutofit/>
-          </a:bodyPr>
-          <a:lstStyle/>
-          <a:p>
-            <a:pPr marL="0" indent="0" algn="ctr">
-              <a:spcBef>
-                <a:spcPts val="0"/>
-              </a:spcBef>
-              <a:buNone/>
-            </a:pPr>
-            <a:r>
-              <a:rPr lang="en" sz="1400">
-                <a:solidFill>
-                  <a:schemeClr val="dk1"/>
-                </a:solidFill>
-                <a:latin typeface="Roboto Mono"/>
-                <a:ea typeface="Roboto Mono"/>
-                <a:cs typeface="Roboto Mono"/>
-                <a:sym typeface="Roboto Mono"/>
-              </a:rPr>
-              <a:t>Ranger</a:t>
-            </a:r>
-          </a:p>
-        </p:txBody>
-      </p:sp>
-      <p:pic>
-        <p:nvPicPr>
-          <p:cNvPr id="906" name="Window bar" descr=""/>
-          <p:cNvPicPr>
-            <a:picLocks noChangeAspect="1"/>
-          </p:cNvPicPr>
-          <p:nvPr/>
-        </p:nvPicPr>
-        <p:blipFill>
-          <a:blip r:embed="rId3"/>
-          <a:srcRect l="80533"/>
-          <a:stretch/>
-        </p:blipFill>
-        <p:spPr>
-          <a:xfrm>
-            <a:off x="4450000" y="3150000"/>
-            <a:ext cx="1450000" cy="265500"/>
-          </a:xfrm>
-          <a:prstGeom prst="rect">
-            <a:avLst/>
-          </a:prstGeom>
-        </p:spPr>
-      </p:pic>
-      <p:sp>
-        <p:nvSpPr>
-          <p:cNvPr id="907" name="Panel"/>
-          <p:cNvSpPr/>
-          <p:nvPr/>
-        </p:nvSpPr>
-        <p:spPr>
-          <a:xfrm>
-            <a:off x="4450000" y="3415500"/>
-            <a:ext cx="1450000" cy="800000"/>
-          </a:xfrm>
-          <a:prstGeom prst="rect">
-            <a:avLst/>
-          </a:prstGeom>
-          <a:solidFill>
-            <a:srgbClr val="EFEFEF"/>
-          </a:solidFill>
-          <a:ln w="12700">
-            <a:solidFill>
-              <a:srgbClr val="707070"/>
-            </a:solidFill>
-          </a:ln>
-        </p:spPr>
-        <p:txBody>
-          <a:bodyPr wrap="square" lIns="91425" tIns="45720" rIns="91425" bIns="45720" anchor="ctr">
-            <a:noAutofit/>
-          </a:bodyPr>
-          <a:lstStyle/>
-          <a:p>
-            <a:pPr marL="0" indent="0" algn="ctr">
-              <a:spcBef>
-                <a:spcPts val="0"/>
-              </a:spcBef>
-              <a:buNone/>
-            </a:pPr>
-            <a:r>
-              <a:rPr lang="en" sz="1400">
-                <a:solidFill>
-                  <a:schemeClr val="dk1"/>
-                </a:solidFill>
-                <a:latin typeface="Roboto Mono"/>
-                <a:ea typeface="Roboto Mono"/>
-                <a:cs typeface="Roboto Mono"/>
-                <a:sym typeface="Roboto Mono"/>
-              </a:rPr>
-              <a:t>Follow-up</a:t>
-            </a:r>
-          </a:p>
-        </p:txBody>
-      </p:sp>
-      <p:sp>
-        <p:nvSpPr>
-          <p:cNvPr id="908" name="Text"/>
-          <p:cNvSpPr txBox="1"/>
-          <p:nvPr/>
-        </p:nvSpPr>
-        <p:spPr>
-          <a:xfrm>
-            <a:off x="1900000" y="3415500"/>
-            <a:ext cx="550000" cy="800000"/>
-          </a:xfrm>
-          <a:prstGeom prst="rect">
-            <a:avLst/>
-          </a:prstGeom>
-          <a:noFill/>
-        </p:spPr>
-        <p:txBody>
-          <a:bodyPr wrap="square" lIns="91425" tIns="91425" rIns="91425" bIns="91425" anchor="ctr">
-            <a:noAutofit/>
-          </a:bodyPr>
-          <a:lstStyle/>
-          <a:p>
-            <a:pPr marL="0" indent="0" algn="ctr">
-              <a:spcBef>
-                <a:spcPts val="0"/>
-              </a:spcBef>
-              <a:buNone/>
-            </a:pPr>
-            <a:r>
-              <a:rPr lang="en" sz="3200">
-                <a:solidFill>
-                  <a:schemeClr val="dk1"/>
-                </a:solidFill>
-                <a:latin typeface="VT323"/>
-                <a:ea typeface="VT323"/>
-                <a:cs typeface="VT323"/>
-                <a:sym typeface="VT323"/>
-              </a:rPr>
-              <a:t>→?</a:t>
-            </a:r>
-          </a:p>
-        </p:txBody>
-      </p:sp>
-      <p:sp>
-        <p:nvSpPr>
-          <p:cNvPr id="909" name="Text"/>
-          <p:cNvSpPr txBox="1"/>
-          <p:nvPr/>
-        </p:nvSpPr>
-        <p:spPr>
-          <a:xfrm>
-            <a:off x="3900000" y="3415500"/>
-            <a:ext cx="550000" cy="800000"/>
-          </a:xfrm>
-          <a:prstGeom prst="rect">
-            <a:avLst/>
-          </a:prstGeom>
-          <a:noFill/>
-        </p:spPr>
-        <p:txBody>
-          <a:bodyPr wrap="square" lIns="91425" tIns="91425" rIns="91425" bIns="91425" anchor="ctr">
-            <a:noAutofit/>
-          </a:bodyPr>
-          <a:lstStyle/>
-          <a:p>
-            <a:pPr marL="0" indent="0" algn="ctr">
-              <a:spcBef>
-                <a:spcPts val="0"/>
-              </a:spcBef>
-              <a:buNone/>
-            </a:pPr>
-            <a:r>
-              <a:rPr lang="en" sz="3200">
-                <a:solidFill>
-                  <a:schemeClr val="dk1"/>
-                </a:solidFill>
-                <a:latin typeface="VT323"/>
-                <a:ea typeface="VT323"/>
-                <a:cs typeface="VT323"/>
-                <a:sym typeface="VT323"/>
-              </a:rPr>
-              <a:t>→?</a:t>
-            </a:r>
-          </a:p>
-        </p:txBody>
-      </p:sp>
-      <p:pic>
-        <p:nvPicPr>
-          <p:cNvPr id="910" name="Window bar" descr=""/>
-          <p:cNvPicPr>
-            <a:picLocks noChangeAspect="1"/>
-          </p:cNvPicPr>
-          <p:nvPr/>
-        </p:nvPicPr>
-        <p:blipFill>
-          <a:blip r:embed="rId3"/>
-          <a:srcRect l="66133"/>
-          <a:stretch/>
-        </p:blipFill>
-        <p:spPr>
-          <a:xfrm>
-            <a:off x="6288700" y="1750000"/>
-            <a:ext cx="2522600" cy="265500"/>
-          </a:xfrm>
-          <a:prstGeom prst="rect">
-            <a:avLst/>
-          </a:prstGeom>
-        </p:spPr>
-      </p:pic>
-      <p:pic>
-        <p:nvPicPr>
-          <p:cNvPr id="911" name="Picture" descr="Report form guide titled Is it a bloom, with drawings of what looks like a bloom and what is often mistaken for one"/>
-          <p:cNvPicPr>
-            <a:picLocks noChangeAspect="1"/>
-          </p:cNvPicPr>
-          <p:nvPr/>
-        </p:nvPicPr>
-        <p:blipFill>
-          <a:blip r:embed="rId4"/>
-          <a:stretch>
-            <a:fillRect/>
-          </a:stretch>
-        </p:blipFill>
-        <p:spPr>
-          <a:xfrm>
-            <a:off x="6300000" y="2015500"/>
-            <a:ext cx="2500000" cy="1639344"/>
           </a:xfrm>
           <a:prstGeom prst="rect">
             <a:avLst/>
@@ -18246,7 +17698,7 @@
         </p:nvSpPr>
         <p:spPr>
           <a:xfrm>
-            <a:off x="3465325" y="3800000"/>
+            <a:off x="3465325" y="3740000"/>
             <a:ext cx="5174400" cy="850000"/>
           </a:xfrm>
           <a:prstGeom prst="rect">
@@ -18271,13 +17723,13 @@
                   <a:schemeClr val="dk1"/>
                 </a:solidFill>
               </a:rPr>
-              <a:t>Report → Review → Prioritize sampling → Share the outcome</a:t>
+              <a:t>Citizen observation → Ranger review → Sampling priority → Reporter feedback</a:t>
             </a:r>
           </a:p>
           <a:p>
             <a:pPr marL="0" indent="0" algn="l">
               <a:spcBef>
-                <a:spcPts val="600"/>
+                <a:spcPts val="200"/>
               </a:spcBef>
               <a:buNone/>
             </a:pPr>
@@ -18287,7 +17739,23 @@
                   <a:schemeClr val="dk1"/>
                 </a:solidFill>
               </a:rPr>
-              <a:t>Lake Mead pilot · Track 6: Resilience Informatics</a:t>
+              <a:t>Track 6: Resilience Informatics</a:t>
+            </a:r>
+          </a:p>
+          <a:p>
+            <a:pPr marL="0" indent="0" algn="l">
+              <a:spcBef>
+                <a:spcPts val="200"/>
+              </a:spcBef>
+              <a:buNone/>
+            </a:pPr>
+            <a:r>
+              <a:rPr lang="en" sz="1200">
+                <a:solidFill>
+                  <a:schemeClr val="dk1"/>
+                </a:solidFill>
+              </a:rPr>
+              <a:t>Lake Mead: pilot workflow · Coimbra: OneAquaHealth application</a:t>
             </a:r>
           </a:p>
         </p:txBody>
@@ -18327,7 +17795,7 @@
                   <a:schemeClr val="dk1"/>
                 </a:solidFill>
               </a:rPr>
-              <a:t>Verdant: from observation to follow-up</a:t>
+              <a:t>Turn an observation into useful follow-up.</a:t>
             </a:r>
           </a:p>
         </p:txBody>
@@ -18461,7 +17929,7 @@
                   <a:schemeClr val="dk1"/>
                 </a:solidFill>
               </a:rPr>
-              <a:t>Better observations. Clearer priorities. Visible follow-up.</a:t>
+              <a:t>From a working demonstration to field use</a:t>
             </a:r>
           </a:p>
         </p:txBody>
@@ -18476,8 +17944,8 @@
         </p:nvSpPr>
         <p:spPr>
           <a:xfrm>
-            <a:off x="342736" y="2040000"/>
-            <a:ext cx="2650000" cy="520000"/>
+            <a:off x="433000" y="1700000"/>
+            <a:ext cx="3700000" cy="1100000"/>
           </a:xfrm>
           <a:prstGeom prst="rect">
             <a:avLst/>
@@ -18501,7 +17969,39 @@
                   <a:schemeClr val="dk1"/>
                 </a:solidFill>
               </a:rPr>
-              <a:t>Guided reports and feedback</a:t>
+              <a:t>Guided reporting and outcome history</a:t>
+            </a:r>
+          </a:p>
+          <a:p>
+            <a:pPr marL="0" indent="0" algn="l">
+              <a:spcBef>
+                <a:spcPts val="400"/>
+              </a:spcBef>
+              <a:buNone/>
+            </a:pPr>
+            <a:r>
+              <a:rPr lang="en" sz="1200">
+                <a:solidFill>
+                  <a:schemeClr val="dk1"/>
+                </a:solidFill>
+              </a:rPr>
+              <a:t>Explainable scoring and regional configuration</a:t>
+            </a:r>
+          </a:p>
+          <a:p>
+            <a:pPr marL="0" indent="0" algn="l">
+              <a:spcBef>
+                <a:spcPts val="400"/>
+              </a:spcBef>
+              <a:buNone/>
+            </a:pPr>
+            <a:r>
+              <a:rPr lang="en" sz="1200">
+                <a:solidFill>
+                  <a:schemeClr val="dk1"/>
+                </a:solidFill>
+              </a:rPr>
+              <a:t>Demonstrated ranger-review workflow</a:t>
             </a:r>
           </a:p>
         </p:txBody>
@@ -18516,8 +18016,8 @@
         </p:nvSpPr>
         <p:spPr>
           <a:xfrm>
-            <a:off x="3239948" y="2040000"/>
-            <a:ext cx="2650000" cy="520000"/>
+            <a:off x="4200000" y="1700000"/>
+            <a:ext cx="4550000" cy="1100000"/>
           </a:xfrm>
           <a:prstGeom prst="rect">
             <a:avLst/>
@@ -18541,37 +18041,13 @@
                   <a:schemeClr val="dk1"/>
                 </a:solidFill>
               </a:rPr>
-              <a:t>Explainable sampling priorities</a:t>
+              <a:t>Test reporting with citizens and rangers</a:t>
             </a:r>
           </a:p>
-        </p:txBody>
-      </p:sp>
-      <p:sp>
-        <p:nvSpPr>
-          <p:cNvPr id="301" name="Google Shape;301;p36"/>
-          <p:cNvSpPr txBox="1"/>
-          <p:nvPr>
-            <p:ph idx="5" type="subTitle"/>
-          </p:nvPr>
-        </p:nvSpPr>
-        <p:spPr>
-          <a:xfrm>
-            <a:off x="6132612" y="2040000"/>
-            <a:ext cx="2650000" cy="520000"/>
-          </a:xfrm>
-          <a:prstGeom prst="rect">
-            <a:avLst/>
-          </a:prstGeom>
-        </p:spPr>
-        <p:txBody>
-          <a:bodyPr anchorCtr="0" anchor="t" bIns="91425" lIns="91425" spcFirstLastPara="1" rIns="91425" wrap="square" tIns="91425">
-            <a:noAutofit/>
-          </a:bodyPr>
-          <a:lstStyle/>
           <a:p>
             <a:pPr marL="0" indent="0" algn="l">
               <a:spcBef>
-                <a:spcPts val="0"/>
+                <a:spcPts val="400"/>
               </a:spcBef>
               <a:buNone/>
             </a:pPr>
@@ -18581,47 +18057,23 @@
                   <a:schemeClr val="dk1"/>
                 </a:solidFill>
               </a:rPr>
-              <a:t>Connect environmental, human, and animal concerns</a:t>
+              <a:t>Compare scores with field measurements</a:t>
             </a:r>
           </a:p>
-        </p:txBody>
-      </p:sp>
-      <p:sp>
-        <p:nvSpPr>
-          <p:cNvPr id="304" name="Google Shape;304;p36"/>
-          <p:cNvSpPr txBox="1"/>
-          <p:nvPr>
-            <p:ph idx="8" type="title"/>
-          </p:nvPr>
-        </p:nvSpPr>
-        <p:spPr>
-          <a:xfrm>
-            <a:off x="6132612" y="1590000"/>
-            <a:ext cx="2650000" cy="450000"/>
-          </a:xfrm>
-          <a:prstGeom prst="rect">
-            <a:avLst/>
-          </a:prstGeom>
-        </p:spPr>
-        <p:txBody>
-          <a:bodyPr anchorCtr="0" anchor="ctr" bIns="91425" lIns="91425" spcFirstLastPara="1" rIns="91425" wrap="square" tIns="91425">
-            <a:noAutofit/>
-          </a:bodyPr>
-          <a:lstStyle/>
           <a:p>
             <a:pPr marL="0" indent="0" algn="l">
               <a:spcBef>
-                <a:spcPts val="0"/>
+                <a:spcPts val="400"/>
               </a:spcBef>
               <a:buNone/>
             </a:pPr>
             <a:r>
-              <a:rPr lang="en" sz="1800">
+              <a:rPr lang="en" sz="1200">
                 <a:solidFill>
                   <a:schemeClr val="dk1"/>
                 </a:solidFill>
               </a:rPr>
-              <a:t>One Health</a:t>
+              <a:t>Shared backend, ranger authentication, duplicate controls</a:t>
             </a:r>
           </a:p>
         </p:txBody>
@@ -18636,8 +18088,8 @@
         </p:nvSpPr>
         <p:spPr>
           <a:xfrm>
-            <a:off x="3239948" y="1590000"/>
-            <a:ext cx="2650000" cy="450000"/>
+            <a:off x="4200000" y="1250000"/>
+            <a:ext cx="4550000" cy="450000"/>
           </a:xfrm>
           <a:prstGeom prst="rect">
             <a:avLst/>
@@ -18661,7 +18113,7 @@
                   <a:schemeClr val="dk1"/>
                 </a:solidFill>
               </a:rPr>
-              <a:t>Rangers and managers</a:t>
+              <a:t>Next validation and deployment steps</a:t>
             </a:r>
           </a:p>
         </p:txBody>
@@ -18676,8 +18128,8 @@
         </p:nvSpPr>
         <p:spPr>
           <a:xfrm>
-            <a:off x="342736" y="1590000"/>
-            <a:ext cx="2650000" cy="450000"/>
+            <a:off x="433000" y="1250000"/>
+            <a:ext cx="3700000" cy="450000"/>
           </a:xfrm>
           <a:prstGeom prst="rect">
             <a:avLst/>
@@ -18701,7 +18153,7 @@
                   <a:schemeClr val="dk1"/>
                 </a:solidFill>
               </a:rPr>
-              <a:t>People at the shore</a:t>
+              <a:t>Working now</a:t>
             </a:r>
           </a:p>
         </p:txBody>
@@ -18721,8 +18173,8 @@
         </p:blipFill>
         <p:spPr>
           <a:xfrm>
-            <a:off x="422861" y="2590000"/>
-            <a:ext cx="2672600" cy="265500"/>
+            <a:off x="433000" y="2900000"/>
+            <a:ext cx="2138080" cy="212400"/>
           </a:xfrm>
           <a:prstGeom prst="rect">
             <a:avLst/>
@@ -18745,8 +18197,8 @@
         </p:blipFill>
         <p:spPr>
           <a:xfrm>
-            <a:off x="434161" y="2855500"/>
-            <a:ext cx="2650000" cy="1300000"/>
+            <a:off x="444300" y="3112400"/>
+            <a:ext cx="2120000" cy="1040000"/>
           </a:xfrm>
           <a:prstGeom prst="rect">
             <a:avLst/>
@@ -18773,8 +18225,8 @@
         </p:blipFill>
         <p:spPr>
           <a:xfrm>
-            <a:off x="3320073" y="2590000"/>
-            <a:ext cx="2672600" cy="265500"/>
+            <a:off x="4200000" y="2900000"/>
+            <a:ext cx="2138080" cy="212400"/>
           </a:xfrm>
           <a:prstGeom prst="rect">
             <a:avLst/>
@@ -18797,60 +18249,8 @@
         </p:blipFill>
         <p:spPr>
           <a:xfrm>
-            <a:off x="3331373" y="2855500"/>
-            <a:ext cx="2650000" cy="1300000"/>
-          </a:xfrm>
-          <a:prstGeom prst="rect">
-            <a:avLst/>
-          </a:prstGeom>
-          <a:ln w="9525">
-            <a:solidFill>
-              <a:srgbClr val="707070"/>
-            </a:solidFill>
-          </a:ln>
-        </p:spPr>
-      </p:pic>
-      <p:pic>
-        <p:nvPicPr>
-          <p:cNvPr id="905" name="Window bar" descr=""/>
-          <p:cNvPicPr>
-            <a:picLocks noChangeAspect="1"/>
-          </p:cNvPicPr>
-          <p:nvPr/>
-        </p:nvPicPr>
-        <p:blipFill>
-          <a:blip r:embed="rId3"/>
-          <a:srcRect l="64119"/>
-          <a:stretch/>
-        </p:blipFill>
-        <p:spPr>
-          <a:xfrm>
-            <a:off x="6212737" y="2590000"/>
-            <a:ext cx="2672600" cy="265500"/>
-          </a:xfrm>
-          <a:prstGeom prst="rect">
-            <a:avLst/>
-          </a:prstGeom>
-        </p:spPr>
-      </p:pic>
-      <p:pic>
-        <p:nvPicPr>
-          <p:cNvPr id="906" name="Screenshot" descr="One Health section of a site page"/>
-          <p:cNvPicPr>
-            <a:picLocks noChangeAspect="1"/>
-          </p:cNvPicPr>
-          <p:nvPr/>
-        </p:nvPicPr>
-        <p:blipFill>
-          <a:blip r:embed="rId6"/>
-          <a:stretch>
-            <a:fillRect/>
-          </a:stretch>
-        </p:blipFill>
-        <p:spPr>
-          <a:xfrm>
-            <a:off x="6224037" y="2855500"/>
-            <a:ext cx="2650000" cy="1300000"/>
+            <a:off x="4211300" y="3112400"/>
+            <a:ext cx="2120000" cy="1040000"/>
           </a:xfrm>
           <a:prstGeom prst="rect">
             <a:avLst/>
@@ -18870,7 +18270,7 @@
         </p:nvSpPr>
         <p:spPr>
           <a:xfrm>
-            <a:off x="433000" y="4260000"/>
+            <a:off x="433000" y="4300000"/>
             <a:ext cx="8300000" cy="280000"/>
           </a:xfrm>
           <a:prstGeom prst="rect">
@@ -18907,50 +18307,7 @@
                 <a:cs typeface="Roboto Mono"/>
                 <a:sym typeface="Roboto Mono"/>
               </a:rPr>
-              <a:t>Next: field validation · shared reporting backend · operational agency data</a:t>
-            </a:r>
-          </a:p>
-        </p:txBody>
-      </p:sp>
-      <p:sp>
-        <p:nvSpPr>
-          <p:cNvPr id="908" name="Text"/>
-          <p:cNvSpPr txBox="1"/>
-          <p:nvPr/>
-        </p:nvSpPr>
-        <p:spPr>
-          <a:xfrm>
-            <a:off x="341850" y="4520000"/>
-            <a:ext cx="8400000" cy="330000"/>
-          </a:xfrm>
-          <a:prstGeom prst="rect">
-            <a:avLst/>
-          </a:prstGeom>
-          <a:noFill/>
-        </p:spPr>
-        <p:txBody>
-          <a:bodyPr wrap="square" lIns="91425" tIns="91425" rIns="91425" bIns="91425" anchor="t">
-            <a:noAutofit/>
-          </a:bodyPr>
-          <a:lstStyle/>
-          <a:p>
-            <a:pPr marL="0" indent="0" algn="l">
-              <a:spcBef>
-                <a:spcPts val="0"/>
-              </a:spcBef>
-              <a:buNone/>
-            </a:pPr>
-            <a:r>
-              <a:rPr lang="en" sz="1200">
-                <a:solidFill>
-                  <a:schemeClr val="dk1"/>
-                </a:solidFill>
-                <a:latin typeface="Roboto Mono"/>
-                <a:ea typeface="Roboto Mono"/>
-                <a:cs typeface="Roboto Mono"/>
-                <a:sym typeface="Roboto Mono"/>
-              </a:rPr>
-              <a:t>Prototype — scores unvalidated; ranger outcomes simulated</a:t>
+              <a:t>Intended impact: more useful reports · clearer sampling priorities · visible follow-up</a:t>
             </a:r>
           </a:p>
         </p:txBody>
@@ -19055,7 +18412,7 @@
                   <a:schemeClr val="dk1"/>
                 </a:solidFill>
               </a:rPr>
-              <a:t>See the bloom before it becomes a warning.</a:t>
+              <a:t>Better observations. Clearer priorities. Visible follow-up.</a:t>
             </a:r>
           </a:p>
           <a:p>

</xml_diff>

<commit_message>
Polish the presentation layout and refresh the slide picture
</commit_message>
<xml_diff>
--- a/docs/presentation/verdant-presentation.pptx
+++ b/docs/presentation/verdant-presentation.pptx
@@ -9809,8 +9809,8 @@
         </p:blipFill>
         <p:spPr>
           <a:xfrm>
-            <a:off x="3233000" y="3371475"/>
-            <a:ext cx="5515599" cy="1351825"/>
+            <a:off x="2164599" y="3109600"/>
+            <a:ext cx="6584000" cy="1613700"/>
           </a:xfrm>
           <a:prstGeom prst="rect">
             <a:avLst/>
@@ -17187,8 +17187,8 @@
         </p:nvSpPr>
         <p:spPr>
           <a:xfrm>
-            <a:off x="341850" y="654800"/>
-            <a:ext cx="8249700" cy="602700"/>
+            <a:off x="338328" y="713232"/>
+            <a:ext cx="5852160" cy="1143000"/>
           </a:xfrm>
           <a:prstGeom prst="rect">
             <a:avLst/>
@@ -17207,7 +17207,7 @@
               <a:buNone/>
             </a:pPr>
             <a:r>
-              <a:rPr lang="en" sz="2400">
+              <a:rPr lang="en">
                 <a:solidFill>
                   <a:schemeClr val="dk1"/>
                 </a:solidFill>
@@ -17227,7 +17227,7 @@
         </p:nvSpPr>
         <p:spPr>
           <a:xfrm>
-            <a:off x="3145041" y="2500000"/>
+            <a:off x="3145041" y="3310128"/>
             <a:ext cx="2599200" cy="450000"/>
           </a:xfrm>
           <a:prstGeom prst="rect">
@@ -17267,7 +17267,7 @@
         </p:nvSpPr>
         <p:spPr>
           <a:xfrm>
-            <a:off x="341850" y="2500000"/>
+            <a:off x="341850" y="3310128"/>
             <a:ext cx="2599200" cy="450000"/>
           </a:xfrm>
           <a:prstGeom prst="rect">
@@ -17307,7 +17307,7 @@
         </p:nvSpPr>
         <p:spPr>
           <a:xfrm>
-            <a:off x="5948257" y="2500000"/>
+            <a:off x="5948257" y="3310128"/>
             <a:ext cx="2599200" cy="450000"/>
           </a:xfrm>
           <a:prstGeom prst="rect">
@@ -17347,7 +17347,7 @@
         </p:nvSpPr>
         <p:spPr>
           <a:xfrm>
-            <a:off x="3145041" y="1650000"/>
+            <a:off x="3145041" y="2487168"/>
             <a:ext cx="2599200" cy="850000"/>
           </a:xfrm>
           <a:prstGeom prst="rect">
@@ -17387,7 +17387,7 @@
         </p:nvSpPr>
         <p:spPr>
           <a:xfrm>
-            <a:off x="341850" y="1650000"/>
+            <a:off x="341850" y="2487168"/>
             <a:ext cx="2599200" cy="850000"/>
           </a:xfrm>
           <a:prstGeom prst="rect">
@@ -17427,7 +17427,7 @@
         </p:nvSpPr>
         <p:spPr>
           <a:xfrm>
-            <a:off x="5948257" y="1650000"/>
+            <a:off x="5948257" y="2487168"/>
             <a:ext cx="2599200" cy="850000"/>
           </a:xfrm>
           <a:prstGeom prst="rect">
@@ -17465,8 +17465,8 @@
         </p:nvSpPr>
         <p:spPr>
           <a:xfrm>
-            <a:off x="341850" y="3100000"/>
-            <a:ext cx="5800000" cy="450000"/>
+            <a:off x="338328" y="3813048"/>
+            <a:ext cx="5486400" cy="450000"/>
           </a:xfrm>
           <a:prstGeom prst="rect">
             <a:avLst/>
@@ -17508,7 +17508,7 @@
         </p:nvSpPr>
         <p:spPr>
           <a:xfrm>
-            <a:off x="341850" y="3600000"/>
+            <a:off x="338328" y="4133088"/>
             <a:ext cx="5800000" cy="400000"/>
           </a:xfrm>
           <a:prstGeom prst="rect">
@@ -17551,8 +17551,8 @@
         </p:nvSpPr>
         <p:spPr>
           <a:xfrm>
-            <a:off x="341850" y="1230000"/>
-            <a:ext cx="8249700" cy="400000"/>
+            <a:off x="338328" y="2011680"/>
+            <a:ext cx="5852160" cy="402336"/>
           </a:xfrm>
           <a:prstGeom prst="rect">
             <a:avLst/>
@@ -17601,8 +17601,8 @@
         </p:blipFill>
         <p:spPr>
           <a:xfrm>
-            <a:off x="6338700" y="3150000"/>
-            <a:ext cx="2472600" cy="265500"/>
+            <a:off x="6492240" y="914400"/>
+            <a:ext cx="2103120" cy="225765"/>
           </a:xfrm>
           <a:prstGeom prst="rect">
             <a:avLst/>
@@ -17625,8 +17625,8 @@
         </p:blipFill>
         <p:spPr>
           <a:xfrm>
-            <a:off x="6350000" y="3415500"/>
-            <a:ext cx="2450000" cy="1300000"/>
+            <a:off x="6501841" y="1140165"/>
+            <a:ext cx="2084832" cy="1105784"/>
           </a:xfrm>
           <a:prstGeom prst="rect">
             <a:avLst/>
@@ -17680,7 +17680,7 @@
         </p:blipFill>
         <p:spPr>
           <a:xfrm>
-            <a:off x="6250000" y="1212525"/>
+            <a:off x="6250000" y="1121085"/>
             <a:ext cx="2500000" cy="1842105"/>
           </a:xfrm>
           <a:prstGeom prst="rect">
@@ -17698,8 +17698,8 @@
         </p:nvSpPr>
         <p:spPr>
           <a:xfrm>
-            <a:off x="3465325" y="3740000"/>
-            <a:ext cx="5174400" cy="850000"/>
+            <a:off x="2313432" y="3739896"/>
+            <a:ext cx="6290000" cy="832000"/>
           </a:xfrm>
           <a:prstGeom prst="rect">
             <a:avLst/>
@@ -17729,7 +17729,7 @@
           <a:p>
             <a:pPr marL="0" indent="0" algn="l">
               <a:spcBef>
-                <a:spcPts val="200"/>
+                <a:spcPts val="400"/>
               </a:spcBef>
               <a:buNone/>
             </a:pPr>
@@ -17745,7 +17745,7 @@
           <a:p>
             <a:pPr marL="0" indent="0" algn="l">
               <a:spcBef>
-                <a:spcPts val="200"/>
+                <a:spcPts val="400"/>
               </a:spcBef>
               <a:buNone/>
             </a:pPr>
@@ -17808,9 +17808,9 @@
         </p:nvGrpSpPr>
         <p:grpSpPr>
           <a:xfrm>
-            <a:off x="6250000" y="947025"/>
+            <a:off x="6250000" y="855585"/>
             <a:ext cx="2500000" cy="265500"/>
-            <a:chOff x="6250000" y="947025"/>
+            <a:chOff x="6250000" y="855585"/>
             <a:chExt cx="2500000" cy="265500"/>
           </a:xfrm>
         </p:grpSpPr>
@@ -17829,7 +17829,7 @@
           </p:blipFill>
           <p:spPr>
             <a:xfrm>
-              <a:off x="6250000" y="947025"/>
+              <a:off x="6250000" y="855585"/>
               <a:ext cx="2500000" cy="265500"/>
             </a:xfrm>
             <a:prstGeom prst="rect">
@@ -17856,7 +17856,7 @@
           </p:blipFill>
           <p:spPr>
             <a:xfrm>
-              <a:off x="6250000" y="947025"/>
+              <a:off x="6250000" y="855585"/>
               <a:ext cx="2500000" cy="265500"/>
             </a:xfrm>
             <a:prstGeom prst="rect">
@@ -17944,8 +17944,8 @@
         </p:nvSpPr>
         <p:spPr>
           <a:xfrm>
-            <a:off x="433000" y="1700000"/>
-            <a:ext cx="3700000" cy="1100000"/>
+            <a:off x="429768" y="1700000"/>
+            <a:ext cx="3931920" cy="1100000"/>
           </a:xfrm>
           <a:prstGeom prst="rect">
             <a:avLst/>
@@ -18016,8 +18016,8 @@
         </p:nvSpPr>
         <p:spPr>
           <a:xfrm>
-            <a:off x="4200000" y="1700000"/>
-            <a:ext cx="4550000" cy="1100000"/>
+            <a:off x="4315968" y="1700000"/>
+            <a:ext cx="3657600" cy="1100000"/>
           </a:xfrm>
           <a:prstGeom prst="rect">
             <a:avLst/>
@@ -18088,8 +18088,8 @@
         </p:nvSpPr>
         <p:spPr>
           <a:xfrm>
-            <a:off x="4200000" y="1250000"/>
-            <a:ext cx="4550000" cy="450000"/>
+            <a:off x="4315968" y="1250000"/>
+            <a:ext cx="4599432" cy="450000"/>
           </a:xfrm>
           <a:prstGeom prst="rect">
             <a:avLst/>
@@ -18173,7 +18173,7 @@
         </p:blipFill>
         <p:spPr>
           <a:xfrm>
-            <a:off x="433000" y="2900000"/>
+            <a:off x="433000" y="2807208"/>
             <a:ext cx="2138080" cy="212400"/>
           </a:xfrm>
           <a:prstGeom prst="rect">
@@ -18197,7 +18197,7 @@
         </p:blipFill>
         <p:spPr>
           <a:xfrm>
-            <a:off x="444300" y="3112400"/>
+            <a:off x="444300" y="3017520"/>
             <a:ext cx="2120000" cy="1040000"/>
           </a:xfrm>
           <a:prstGeom prst="rect">
@@ -18225,7 +18225,7 @@
         </p:blipFill>
         <p:spPr>
           <a:xfrm>
-            <a:off x="4200000" y="2900000"/>
+            <a:off x="4315968" y="2807208"/>
             <a:ext cx="2138080" cy="212400"/>
           </a:xfrm>
           <a:prstGeom prst="rect">
@@ -18249,7 +18249,7 @@
         </p:blipFill>
         <p:spPr>
           <a:xfrm>
-            <a:off x="4211300" y="3112400"/>
+            <a:off x="4334256" y="3017520"/>
             <a:ext cx="2120000" cy="1040000"/>
           </a:xfrm>
           <a:prstGeom prst="rect">

</xml_diff>

<commit_message>
Fix presentation layout for the template fonts and refresh the slide picture
</commit_message>
<xml_diff>
--- a/docs/presentation/verdant-presentation.pptx
+++ b/docs/presentation/verdant-presentation.pptx
@@ -9809,8 +9809,8 @@
         </p:blipFill>
         <p:spPr>
           <a:xfrm>
-            <a:off x="2164599" y="3109600"/>
-            <a:ext cx="6584000" cy="1613700"/>
+            <a:off x="1179576" y="2926080"/>
+            <a:ext cx="7571232" cy="1847088"/>
           </a:xfrm>
           <a:prstGeom prst="rect">
             <a:avLst/>
@@ -17465,8 +17465,8 @@
         </p:nvSpPr>
         <p:spPr>
           <a:xfrm>
-            <a:off x="338328" y="3813048"/>
-            <a:ext cx="5486400" cy="450000"/>
+            <a:off x="338328" y="3730752"/>
+            <a:ext cx="7863840" cy="450000"/>
           </a:xfrm>
           <a:prstGeom prst="rect">
             <a:avLst/>
@@ -17508,7 +17508,7 @@
         </p:nvSpPr>
         <p:spPr>
           <a:xfrm>
-            <a:off x="338328" y="4133088"/>
+            <a:off x="338328" y="4315968"/>
             <a:ext cx="5800000" cy="400000"/>
           </a:xfrm>
           <a:prstGeom prst="rect">
@@ -17680,8 +17680,8 @@
         </p:blipFill>
         <p:spPr>
           <a:xfrm>
-            <a:off x="6250000" y="1121085"/>
-            <a:ext cx="2500000" cy="1842105"/>
+            <a:off x="6450000" y="1099845"/>
+            <a:ext cx="2300000" cy="1694737"/>
           </a:xfrm>
           <a:prstGeom prst="rect">
             <a:avLst/>
@@ -17698,8 +17698,8 @@
         </p:nvSpPr>
         <p:spPr>
           <a:xfrm>
-            <a:off x="2313432" y="3739896"/>
-            <a:ext cx="6290000" cy="832000"/>
+            <a:off x="1417320" y="3822192"/>
+            <a:ext cx="7269480" cy="822960"/>
           </a:xfrm>
           <a:prstGeom prst="rect">
             <a:avLst/>
@@ -17712,6 +17712,9 @@
           <a:lstStyle/>
           <a:p>
             <a:pPr marL="0" indent="0" algn="l">
+              <a:lnSpc>
+                <a:spcPct val="90000"/>
+              </a:lnSpc>
               <a:spcBef>
                 <a:spcPts val="0"/>
               </a:spcBef>
@@ -17729,7 +17732,7 @@
           <a:p>
             <a:pPr marL="0" indent="0" algn="l">
               <a:spcBef>
-                <a:spcPts val="400"/>
+                <a:spcPts val="200"/>
               </a:spcBef>
               <a:buNone/>
             </a:pPr>
@@ -17745,7 +17748,7 @@
           <a:p>
             <a:pPr marL="0" indent="0" algn="l">
               <a:spcBef>
-                <a:spcPts val="400"/>
+                <a:spcPts val="200"/>
               </a:spcBef>
               <a:buNone/>
             </a:pPr>
@@ -17808,10 +17811,10 @@
         </p:nvGrpSpPr>
         <p:grpSpPr>
           <a:xfrm>
-            <a:off x="6250000" y="855585"/>
-            <a:ext cx="2500000" cy="265500"/>
-            <a:chOff x="6250000" y="855585"/>
-            <a:chExt cx="2500000" cy="265500"/>
+            <a:off x="6450000" y="855585"/>
+            <a:ext cx="2300000" cy="244260"/>
+            <a:chOff x="6450000" y="855585"/>
+            <a:chExt cx="2300000" cy="244260"/>
           </a:xfrm>
         </p:grpSpPr>
         <p:pic>
@@ -17829,8 +17832,8 @@
           </p:blipFill>
           <p:spPr>
             <a:xfrm>
-              <a:off x="6250000" y="855585"/>
-              <a:ext cx="2500000" cy="265500"/>
+              <a:off x="6450000" y="855585"/>
+              <a:ext cx="2300000" cy="244260"/>
             </a:xfrm>
             <a:prstGeom prst="rect">
               <a:avLst/>
@@ -17856,8 +17859,8 @@
           </p:blipFill>
           <p:spPr>
             <a:xfrm>
-              <a:off x="6250000" y="855585"/>
-              <a:ext cx="2500000" cy="265500"/>
+              <a:off x="6450000" y="855585"/>
+              <a:ext cx="2300000" cy="244260"/>
             </a:xfrm>
             <a:prstGeom prst="rect">
               <a:avLst/>
@@ -18017,7 +18020,7 @@
         <p:spPr>
           <a:xfrm>
             <a:off x="4315968" y="1700000"/>
-            <a:ext cx="3657600" cy="1100000"/>
+            <a:ext cx="4434840" cy="1100000"/>
           </a:xfrm>
           <a:prstGeom prst="rect">
             <a:avLst/>
@@ -18173,8 +18176,8 @@
         </p:blipFill>
         <p:spPr>
           <a:xfrm>
-            <a:off x="433000" y="2807208"/>
-            <a:ext cx="2138080" cy="212400"/>
+            <a:off x="429768" y="3200400"/>
+            <a:ext cx="1540581" cy="151425"/>
           </a:xfrm>
           <a:prstGeom prst="rect">
             <a:avLst/>
@@ -18197,8 +18200,8 @@
         </p:blipFill>
         <p:spPr>
           <a:xfrm>
-            <a:off x="444300" y="3017520"/>
-            <a:ext cx="2120000" cy="1040000"/>
+            <a:off x="448056" y="3351825"/>
+            <a:ext cx="1527414" cy="750540"/>
           </a:xfrm>
           <a:prstGeom prst="rect">
             <a:avLst/>
@@ -18225,8 +18228,8 @@
         </p:blipFill>
         <p:spPr>
           <a:xfrm>
-            <a:off x="4315968" y="2807208"/>
-            <a:ext cx="2138080" cy="212400"/>
+            <a:off x="4315968" y="3200400"/>
+            <a:ext cx="1540581" cy="151425"/>
           </a:xfrm>
           <a:prstGeom prst="rect">
             <a:avLst/>
@@ -18249,8 +18252,8 @@
         </p:blipFill>
         <p:spPr>
           <a:xfrm>
-            <a:off x="4334256" y="3017520"/>
-            <a:ext cx="2120000" cy="1040000"/>
+            <a:off x="4334256" y="3351825"/>
+            <a:ext cx="1527414" cy="750540"/>
           </a:xfrm>
           <a:prstGeom prst="rect">
             <a:avLst/>
@@ -18388,7 +18391,7 @@
         <p:spPr>
           <a:xfrm>
             <a:off x="669775" y="1850750"/>
-            <a:ext cx="3700000" cy="1300000"/>
+            <a:ext cx="3886200" cy="1371600"/>
           </a:xfrm>
           <a:prstGeom prst="rect">
             <a:avLst/>
@@ -18552,8 +18555,8 @@
         </p:blipFill>
         <p:spPr>
           <a:xfrm>
-            <a:off x="749900" y="3000000"/>
-            <a:ext cx="3522600" cy="265500"/>
+            <a:off x="749808" y="3310128"/>
+            <a:ext cx="2992374" cy="225400"/>
           </a:xfrm>
           <a:prstGeom prst="rect">
             <a:avLst/>
@@ -18576,8 +18579,8 @@
         </p:blipFill>
         <p:spPr>
           <a:xfrm>
-            <a:off x="761200" y="3265500"/>
-            <a:ext cx="3500000" cy="1234000"/>
+            <a:off x="758952" y="3535528"/>
+            <a:ext cx="2976829" cy="1049274"/>
           </a:xfrm>
           <a:prstGeom prst="rect">
             <a:avLst/>

</xml_diff>